<commit_message>
updated CV and added to companies xcel and presentation
</commit_message>
<xml_diff>
--- a/Market Research Presentation 1.pptx
+++ b/Market Research Presentation 1.pptx
@@ -3600,7 +3600,21 @@
           <a:bodyPr/>
           <a:lstStyle/>
           <a:p>
-            <a:endParaRPr lang="en-IE"/>
+            <a:r>
+              <a:rPr lang="en-IE" dirty="0"/>
+              <a:t>IBM: Technology Research, Charlemont Exchange, WeWork Office Space, Temple Bar, Dublin</a:t>
+            </a:r>
+          </a:p>
+          <a:p>
+            <a:r>
+              <a:rPr lang="en-IE" dirty="0"/>
+              <a:t>Amazon: Shipping </a:t>
+            </a:r>
+            <a:r>
+              <a:rPr lang="en-IE"/>
+              <a:t>and entertainment, Burlington Rd, Dublin 4, D04 HH21</a:t>
+            </a:r>
+            <a:endParaRPr lang="en-IE" dirty="0"/>
           </a:p>
         </p:txBody>
       </p:sp>
@@ -3683,7 +3697,7 @@
           <a:bodyPr/>
           <a:lstStyle/>
           <a:p>
-            <a:endParaRPr lang="en-IE"/>
+            <a:endParaRPr lang="en-IE" dirty="0"/>
           </a:p>
         </p:txBody>
       </p:sp>

</xml_diff>

<commit_message>
Adding to the presentation.
Added what I've learned about getting on Erasmus. (might add more later)
</commit_message>
<xml_diff>
--- a/Market Research Presentation 1.pptx
+++ b/Market Research Presentation 1.pptx
@@ -10,7 +10,8 @@
     <p:sldId id="259" r:id="rId4"/>
     <p:sldId id="260" r:id="rId5"/>
     <p:sldId id="261" r:id="rId6"/>
-    <p:sldId id="258" r:id="rId7"/>
+    <p:sldId id="262" r:id="rId7"/>
+    <p:sldId id="258" r:id="rId8"/>
   </p:sldIdLst>
   <p:sldSz cx="12192000" cy="6858000"/>
   <p:notesSz cx="6858000" cy="9144000"/>
@@ -109,7 +110,41 @@
       </a:defRPr>
     </a:lvl9pPr>
   </p:defaultTextStyle>
+  <p:extLst>
+    <p:ext uri="{EFAFB233-063F-42B5-8137-9DF3F51BA10A}">
+      <p15:sldGuideLst xmlns:p15="http://schemas.microsoft.com/office/powerpoint/2012/main"/>
+    </p:ext>
+  </p:extLst>
 </p:presentation>
+</file>
+
+<file path=ppt/changesInfos/changesInfo1.xml><?xml version="1.0" encoding="utf-8"?>
+<pc:chgInfo xmlns:a="http://schemas.openxmlformats.org/drawingml/2006/main" xmlns:r="http://schemas.openxmlformats.org/officeDocument/2006/relationships" xmlns:ac="http://schemas.microsoft.com/office/drawing/2013/main/command" xmlns:pc="http://schemas.microsoft.com/office/powerpoint/2013/main/command">
+  <pc:docChgLst>
+    <pc:chgData name="Joseph Dodd" userId="3f8da1886193f185" providerId="LiveId" clId="{67C7D629-8EE9-4B75-BFDA-D18D7FACED33}"/>
+    <pc:docChg chg="custSel modSld">
+      <pc:chgData name="Joseph Dodd" userId="3f8da1886193f185" providerId="LiveId" clId="{67C7D629-8EE9-4B75-BFDA-D18D7FACED33}" dt="2026-03-21T19:32:34.540" v="24" actId="20577"/>
+      <pc:docMkLst>
+        <pc:docMk/>
+      </pc:docMkLst>
+      <pc:sldChg chg="modSp mod">
+        <pc:chgData name="Joseph Dodd" userId="3f8da1886193f185" providerId="LiveId" clId="{67C7D629-8EE9-4B75-BFDA-D18D7FACED33}" dt="2026-03-21T19:32:34.540" v="24" actId="20577"/>
+        <pc:sldMkLst>
+          <pc:docMk/>
+          <pc:sldMk cId="3944733211" sldId="256"/>
+        </pc:sldMkLst>
+        <pc:spChg chg="mod">
+          <ac:chgData name="Joseph Dodd" userId="3f8da1886193f185" providerId="LiveId" clId="{67C7D629-8EE9-4B75-BFDA-D18D7FACED33}" dt="2026-03-21T19:32:34.540" v="24" actId="20577"/>
+          <ac:spMkLst>
+            <pc:docMk/>
+            <pc:sldMk cId="3944733211" sldId="256"/>
+            <ac:spMk id="3" creationId="{17FDA15A-C183-0EE1-944D-2AEB4CAF926C}"/>
+          </ac:spMkLst>
+        </pc:spChg>
+      </pc:sldChg>
+    </pc:docChg>
+  </pc:docChgLst>
+</pc:chgInfo>
 </file>
 
 <file path=ppt/slideLayouts/slideLayout1.xml><?xml version="1.0" encoding="utf-8"?>
@@ -261,7 +296,7 @@
           <a:p>
             <a:fld id="{C732AC28-C3C3-4819-BBB8-35C0E7F8752D}" type="datetimeFigureOut">
               <a:rPr lang="en-IE" smtClean="0"/>
-              <a:t>18/03/2026</a:t>
+              <a:t>21/03/2026</a:t>
             </a:fld>
             <a:endParaRPr lang="en-IE"/>
           </a:p>
@@ -461,7 +496,7 @@
           <a:p>
             <a:fld id="{C732AC28-C3C3-4819-BBB8-35C0E7F8752D}" type="datetimeFigureOut">
               <a:rPr lang="en-IE" smtClean="0"/>
-              <a:t>18/03/2026</a:t>
+              <a:t>21/03/2026</a:t>
             </a:fld>
             <a:endParaRPr lang="en-IE"/>
           </a:p>
@@ -671,7 +706,7 @@
           <a:p>
             <a:fld id="{C732AC28-C3C3-4819-BBB8-35C0E7F8752D}" type="datetimeFigureOut">
               <a:rPr lang="en-IE" smtClean="0"/>
-              <a:t>18/03/2026</a:t>
+              <a:t>21/03/2026</a:t>
             </a:fld>
             <a:endParaRPr lang="en-IE"/>
           </a:p>
@@ -871,7 +906,7 @@
           <a:p>
             <a:fld id="{C732AC28-C3C3-4819-BBB8-35C0E7F8752D}" type="datetimeFigureOut">
               <a:rPr lang="en-IE" smtClean="0"/>
-              <a:t>18/03/2026</a:t>
+              <a:t>21/03/2026</a:t>
             </a:fld>
             <a:endParaRPr lang="en-IE"/>
           </a:p>
@@ -1147,7 +1182,7 @@
           <a:p>
             <a:fld id="{C732AC28-C3C3-4819-BBB8-35C0E7F8752D}" type="datetimeFigureOut">
               <a:rPr lang="en-IE" smtClean="0"/>
-              <a:t>18/03/2026</a:t>
+              <a:t>21/03/2026</a:t>
             </a:fld>
             <a:endParaRPr lang="en-IE"/>
           </a:p>
@@ -1415,7 +1450,7 @@
           <a:p>
             <a:fld id="{C732AC28-C3C3-4819-BBB8-35C0E7F8752D}" type="datetimeFigureOut">
               <a:rPr lang="en-IE" smtClean="0"/>
-              <a:t>18/03/2026</a:t>
+              <a:t>21/03/2026</a:t>
             </a:fld>
             <a:endParaRPr lang="en-IE"/>
           </a:p>
@@ -1830,7 +1865,7 @@
           <a:p>
             <a:fld id="{C732AC28-C3C3-4819-BBB8-35C0E7F8752D}" type="datetimeFigureOut">
               <a:rPr lang="en-IE" smtClean="0"/>
-              <a:t>18/03/2026</a:t>
+              <a:t>21/03/2026</a:t>
             </a:fld>
             <a:endParaRPr lang="en-IE"/>
           </a:p>
@@ -1972,7 +2007,7 @@
           <a:p>
             <a:fld id="{C732AC28-C3C3-4819-BBB8-35C0E7F8752D}" type="datetimeFigureOut">
               <a:rPr lang="en-IE" smtClean="0"/>
-              <a:t>18/03/2026</a:t>
+              <a:t>21/03/2026</a:t>
             </a:fld>
             <a:endParaRPr lang="en-IE"/>
           </a:p>
@@ -2085,7 +2120,7 @@
           <a:p>
             <a:fld id="{C732AC28-C3C3-4819-BBB8-35C0E7F8752D}" type="datetimeFigureOut">
               <a:rPr lang="en-IE" smtClean="0"/>
-              <a:t>18/03/2026</a:t>
+              <a:t>21/03/2026</a:t>
             </a:fld>
             <a:endParaRPr lang="en-IE"/>
           </a:p>
@@ -2398,7 +2433,7 @@
           <a:p>
             <a:fld id="{C732AC28-C3C3-4819-BBB8-35C0E7F8752D}" type="datetimeFigureOut">
               <a:rPr lang="en-IE" smtClean="0"/>
-              <a:t>18/03/2026</a:t>
+              <a:t>21/03/2026</a:t>
             </a:fld>
             <a:endParaRPr lang="en-IE"/>
           </a:p>
@@ -2687,7 +2722,7 @@
           <a:p>
             <a:fld id="{C732AC28-C3C3-4819-BBB8-35C0E7F8752D}" type="datetimeFigureOut">
               <a:rPr lang="en-IE" smtClean="0"/>
-              <a:t>18/03/2026</a:t>
+              <a:t>21/03/2026</a:t>
             </a:fld>
             <a:endParaRPr lang="en-IE"/>
           </a:p>
@@ -2930,7 +2965,7 @@
           <a:p>
             <a:fld id="{C732AC28-C3C3-4819-BBB8-35C0E7F8752D}" type="datetimeFigureOut">
               <a:rPr lang="en-IE" smtClean="0"/>
-              <a:t>18/03/2026</a:t>
+              <a:t>21/03/2026</a:t>
             </a:fld>
             <a:endParaRPr lang="en-IE"/>
           </a:p>
@@ -3409,6 +3444,13 @@
               <a:rPr lang="en-IE" dirty="0"/>
               <a:t>Matthew Vickery – D00190293</a:t>
             </a:r>
+            <a:br>
+              <a:rPr lang="en-IE" dirty="0"/>
+            </a:br>
+            <a:r>
+              <a:rPr lang="en-IE" dirty="0"/>
+              <a:t>Joseph Dodd – D00281162</a:t>
+            </a:r>
           </a:p>
           <a:p>
             <a:endParaRPr lang="en-IE" dirty="0"/>
@@ -3614,13 +3656,8 @@
           <a:p>
             <a:r>
               <a:rPr lang="en-IE" dirty="0"/>
-              <a:t>Prometric</a:t>
-            </a:r>
-            <a:r>
-              <a:rPr lang="en-IE"/>
-              <a:t>: Works on providing the official preparation material for the Road Safety Authority Driver Theory Test, Dundalk</a:t>
-            </a:r>
-            <a:endParaRPr lang="en-IE" dirty="0"/>
+              <a:t>Prometric: Works on providing the official preparation material for the Road Safety Authority Driver Theory Test, Dundalk</a:t>
+            </a:r>
           </a:p>
         </p:txBody>
       </p:sp>
@@ -3804,6 +3841,307 @@
 </file>
 
 <file path=ppt/slides/slide6.xml><?xml version="1.0" encoding="utf-8"?>
+<p:sld xmlns:a="http://schemas.openxmlformats.org/drawingml/2006/main" xmlns:r="http://schemas.openxmlformats.org/officeDocument/2006/relationships" xmlns:p="http://schemas.openxmlformats.org/presentationml/2006/main">
+  <p:cSld>
+    <p:spTree>
+      <p:nvGrpSpPr>
+        <p:cNvPr id="1" name=""/>
+        <p:cNvGrpSpPr/>
+        <p:nvPr/>
+      </p:nvGrpSpPr>
+      <p:grpSpPr>
+        <a:xfrm>
+          <a:off x="0" y="0"/>
+          <a:ext cx="0" cy="0"/>
+          <a:chOff x="0" y="0"/>
+          <a:chExt cx="0" cy="0"/>
+        </a:xfrm>
+      </p:grpSpPr>
+      <p:sp>
+        <p:nvSpPr>
+          <p:cNvPr id="2" name="Title 1">
+            <a:extLst>
+              <a:ext uri="{FF2B5EF4-FFF2-40B4-BE49-F238E27FC236}">
+                <a16:creationId xmlns:a16="http://schemas.microsoft.com/office/drawing/2014/main" id="{27F5DC1E-CDEF-A71D-59E4-250BED6CB783}"/>
+              </a:ext>
+            </a:extLst>
+          </p:cNvPr>
+          <p:cNvSpPr>
+            <a:spLocks noGrp="1"/>
+          </p:cNvSpPr>
+          <p:nvPr>
+            <p:ph type="title"/>
+          </p:nvPr>
+        </p:nvSpPr>
+        <p:spPr/>
+        <p:txBody>
+          <a:bodyPr/>
+          <a:lstStyle/>
+          <a:p>
+            <a:r>
+              <a:rPr lang="en-GB" b="1" u="sng" dirty="0"/>
+              <a:t>Erasmus</a:t>
+            </a:r>
+          </a:p>
+        </p:txBody>
+      </p:sp>
+      <p:pic>
+        <p:nvPicPr>
+          <p:cNvPr id="5" name="Content Placeholder 4">
+            <a:extLst>
+              <a:ext uri="{FF2B5EF4-FFF2-40B4-BE49-F238E27FC236}">
+                <a16:creationId xmlns:a16="http://schemas.microsoft.com/office/drawing/2014/main" id="{901C501F-CF1D-1ADF-3CDE-81F191F8BBE0}"/>
+              </a:ext>
+            </a:extLst>
+          </p:cNvPr>
+          <p:cNvPicPr>
+            <a:picLocks noGrp="1" noChangeAspect="1"/>
+          </p:cNvPicPr>
+          <p:nvPr>
+            <p:ph idx="1"/>
+          </p:nvPr>
+        </p:nvPicPr>
+        <p:blipFill>
+          <a:blip r:embed="rId2"/>
+          <a:stretch>
+            <a:fillRect/>
+          </a:stretch>
+        </p:blipFill>
+        <p:spPr>
+          <a:xfrm>
+            <a:off x="6645657" y="4675965"/>
+            <a:ext cx="2960567" cy="1511714"/>
+          </a:xfrm>
+          <a:prstGeom prst="rect">
+            <a:avLst/>
+          </a:prstGeom>
+        </p:spPr>
+      </p:pic>
+      <p:sp>
+        <p:nvSpPr>
+          <p:cNvPr id="15" name="Text Placeholder 14">
+            <a:extLst>
+              <a:ext uri="{FF2B5EF4-FFF2-40B4-BE49-F238E27FC236}">
+                <a16:creationId xmlns:a16="http://schemas.microsoft.com/office/drawing/2014/main" id="{14FEF3F1-3AA1-E0DF-4C10-1D2430934B14}"/>
+              </a:ext>
+            </a:extLst>
+          </p:cNvPr>
+          <p:cNvSpPr>
+            <a:spLocks noGrp="1"/>
+          </p:cNvSpPr>
+          <p:nvPr>
+            <p:ph type="body" sz="half" idx="2"/>
+          </p:nvPr>
+        </p:nvSpPr>
+        <p:spPr>
+          <a:xfrm>
+            <a:off x="839788" y="2057400"/>
+            <a:ext cx="5561012" cy="3811588"/>
+          </a:xfrm>
+        </p:spPr>
+        <p:txBody>
+          <a:bodyPr>
+            <a:normAutofit fontScale="92500" lnSpcReduction="10000"/>
+          </a:bodyPr>
+          <a:lstStyle/>
+          <a:p>
+            <a:pPr marL="457200" indent="-457200">
+              <a:buFont typeface="Arial" panose="020B0604020202020204" pitchFamily="34" charset="0"/>
+              <a:buChar char="•"/>
+            </a:pPr>
+            <a:r>
+              <a:rPr lang="en-GB" sz="2400" dirty="0"/>
+              <a:t>Fill out “Expression of interest” form.</a:t>
+            </a:r>
+            <a:br>
+              <a:rPr lang="en-GB" sz="2400" dirty="0"/>
+            </a:br>
+            <a:endParaRPr lang="en-GB" sz="2400" dirty="0"/>
+          </a:p>
+          <a:p>
+            <a:pPr marL="457200" indent="-457200">
+              <a:buFont typeface="Arial" panose="020B0604020202020204" pitchFamily="34" charset="0"/>
+              <a:buChar char="•"/>
+            </a:pPr>
+            <a:r>
+              <a:rPr lang="en-GB" sz="2400" dirty="0"/>
+              <a:t>Highlight where you want to go.</a:t>
+            </a:r>
+            <a:br>
+              <a:rPr lang="en-GB" sz="2400" dirty="0"/>
+            </a:br>
+            <a:endParaRPr lang="en-GB" sz="2400" dirty="0"/>
+          </a:p>
+          <a:p>
+            <a:pPr marL="457200" indent="-457200">
+              <a:buFont typeface="Arial" panose="020B0604020202020204" pitchFamily="34" charset="0"/>
+              <a:buChar char="•"/>
+            </a:pPr>
+            <a:r>
+              <a:rPr lang="en-GB" sz="2400" dirty="0"/>
+              <a:t>If on work placement, find accommodation yourself.</a:t>
+            </a:r>
+          </a:p>
+          <a:p>
+            <a:pPr marL="457200" indent="-457200">
+              <a:buFont typeface="Arial" panose="020B0604020202020204" pitchFamily="34" charset="0"/>
+              <a:buChar char="•"/>
+            </a:pPr>
+            <a:r>
+              <a:rPr lang="en-GB" sz="2400" dirty="0"/>
+              <a:t>Or if at a University, on campus accommodations.</a:t>
+            </a:r>
+            <a:br>
+              <a:rPr lang="en-GB" sz="2400" dirty="0"/>
+            </a:br>
+            <a:endParaRPr lang="en-GB" sz="2400" dirty="0"/>
+          </a:p>
+          <a:p>
+            <a:pPr marL="457200" indent="-457200">
+              <a:buFont typeface="Arial" panose="020B0604020202020204" pitchFamily="34" charset="0"/>
+              <a:buChar char="•"/>
+            </a:pPr>
+            <a:r>
+              <a:rPr lang="en-GB" sz="2400" dirty="0"/>
+              <a:t>Each place has its own entry requirements.</a:t>
+            </a:r>
+          </a:p>
+        </p:txBody>
+      </p:sp>
+      <p:pic>
+        <p:nvPicPr>
+          <p:cNvPr id="7" name="Picture 6">
+            <a:extLst>
+              <a:ext uri="{FF2B5EF4-FFF2-40B4-BE49-F238E27FC236}">
+                <a16:creationId xmlns:a16="http://schemas.microsoft.com/office/drawing/2014/main" id="{2DE33657-06A4-7641-9C3C-AB71B389E8D2}"/>
+              </a:ext>
+            </a:extLst>
+          </p:cNvPr>
+          <p:cNvPicPr>
+            <a:picLocks noChangeAspect="1"/>
+          </p:cNvPicPr>
+          <p:nvPr/>
+        </p:nvPicPr>
+        <p:blipFill>
+          <a:blip r:embed="rId3"/>
+          <a:stretch>
+            <a:fillRect/>
+          </a:stretch>
+        </p:blipFill>
+        <p:spPr>
+          <a:xfrm>
+            <a:off x="6645657" y="3662486"/>
+            <a:ext cx="2792908" cy="1013479"/>
+          </a:xfrm>
+          <a:prstGeom prst="rect">
+            <a:avLst/>
+          </a:prstGeom>
+        </p:spPr>
+      </p:pic>
+      <p:pic>
+        <p:nvPicPr>
+          <p:cNvPr id="9" name="Picture 8">
+            <a:extLst>
+              <a:ext uri="{FF2B5EF4-FFF2-40B4-BE49-F238E27FC236}">
+                <a16:creationId xmlns:a16="http://schemas.microsoft.com/office/drawing/2014/main" id="{6D479AD5-36C5-D87B-8E64-486D64BD0AF0}"/>
+              </a:ext>
+            </a:extLst>
+          </p:cNvPr>
+          <p:cNvPicPr>
+            <a:picLocks noChangeAspect="1"/>
+          </p:cNvPicPr>
+          <p:nvPr/>
+        </p:nvPicPr>
+        <p:blipFill>
+          <a:blip r:embed="rId4"/>
+          <a:stretch>
+            <a:fillRect/>
+          </a:stretch>
+        </p:blipFill>
+        <p:spPr>
+          <a:xfrm>
+            <a:off x="9438565" y="3604902"/>
+            <a:ext cx="1629547" cy="1071063"/>
+          </a:xfrm>
+          <a:prstGeom prst="rect">
+            <a:avLst/>
+          </a:prstGeom>
+        </p:spPr>
+      </p:pic>
+      <p:pic>
+        <p:nvPicPr>
+          <p:cNvPr id="11" name="Picture 10">
+            <a:extLst>
+              <a:ext uri="{FF2B5EF4-FFF2-40B4-BE49-F238E27FC236}">
+                <a16:creationId xmlns:a16="http://schemas.microsoft.com/office/drawing/2014/main" id="{CE58E40C-287F-0A49-D596-2610018D0CBC}"/>
+              </a:ext>
+            </a:extLst>
+          </p:cNvPr>
+          <p:cNvPicPr>
+            <a:picLocks noChangeAspect="1"/>
+          </p:cNvPicPr>
+          <p:nvPr/>
+        </p:nvPicPr>
+        <p:blipFill>
+          <a:blip r:embed="rId5"/>
+          <a:stretch>
+            <a:fillRect/>
+          </a:stretch>
+        </p:blipFill>
+        <p:spPr>
+          <a:xfrm>
+            <a:off x="9606225" y="4675966"/>
+            <a:ext cx="1461160" cy="1511714"/>
+          </a:xfrm>
+          <a:prstGeom prst="rect">
+            <a:avLst/>
+          </a:prstGeom>
+        </p:spPr>
+      </p:pic>
+      <p:pic>
+        <p:nvPicPr>
+          <p:cNvPr id="13" name="Picture 12">
+            <a:extLst>
+              <a:ext uri="{FF2B5EF4-FFF2-40B4-BE49-F238E27FC236}">
+                <a16:creationId xmlns:a16="http://schemas.microsoft.com/office/drawing/2014/main" id="{3B4A11B8-13D4-0D0F-7E0C-52B94584F44E}"/>
+              </a:ext>
+            </a:extLst>
+          </p:cNvPr>
+          <p:cNvPicPr>
+            <a:picLocks noChangeAspect="1"/>
+          </p:cNvPicPr>
+          <p:nvPr/>
+        </p:nvPicPr>
+        <p:blipFill>
+          <a:blip r:embed="rId6"/>
+          <a:stretch>
+            <a:fillRect/>
+          </a:stretch>
+        </p:blipFill>
+        <p:spPr>
+          <a:xfrm>
+            <a:off x="6645657" y="670321"/>
+            <a:ext cx="5410669" cy="2758679"/>
+          </a:xfrm>
+          <a:prstGeom prst="rect">
+            <a:avLst/>
+          </a:prstGeom>
+        </p:spPr>
+      </p:pic>
+    </p:spTree>
+    <p:extLst>
+      <p:ext uri="{BB962C8B-B14F-4D97-AF65-F5344CB8AC3E}">
+        <p14:creationId xmlns:p14="http://schemas.microsoft.com/office/powerpoint/2010/main" val="670721749"/>
+      </p:ext>
+    </p:extLst>
+  </p:cSld>
+  <p:clrMapOvr>
+    <a:masterClrMapping/>
+  </p:clrMapOvr>
+</p:sld>
+</file>
+
+<file path=ppt/slides/slide7.xml><?xml version="1.0" encoding="utf-8"?>
 <p:sld xmlns:a="http://schemas.openxmlformats.org/drawingml/2006/main" xmlns:r="http://schemas.openxmlformats.org/officeDocument/2006/relationships" xmlns:p="http://schemas.openxmlformats.org/presentationml/2006/main">
   <p:cSld>
     <p:spTree>

</xml_diff>